<commit_message>
M23: Sim-Review umgesetzt (sim_review true, Inhalt aktualisiert)
Co-Authored-By: Claude Opus 4.8 <noreply@anthropic.com>
</commit_message>
<xml_diff>
--- a/protected-downloads/praesentation/M23.pptx
+++ b/protected-downloads/praesentation/M23.pptx
@@ -5688,7 +5688,7 @@
                 </a:solidFill>
                 <a:latin typeface="Consolas"/>
               </a:rPr>
-              <a:t>16:30–17:00 </a:t>
+              <a:t>16:30–16:40 </a:t>
             </a:r>
             <a:r>
               <a:rPr sz="1200" b="1">
@@ -5697,7 +5697,81 @@
                 </a:solidFill>
                 <a:latin typeface="Arial"/>
               </a:rPr>
-              <a:t>  Abschluss</a:t>
+              <a:t>  Soll-Ist-Abgleich</a:t>
+            </a:r>
+            <a:r>
+              <a:rPr sz="900">
+                <a:solidFill>
+                  <a:srgbClr val="78808C"/>
+                </a:solidFill>
+                <a:latin typeface="Arial"/>
+              </a:rPr>
+              <a:t>  ·  Demo</a:t>
+            </a:r>
+          </a:p>
+          <a:p>
+            <a:pPr>
+              <a:spcBef>
+                <a:spcPts val="400"/>
+              </a:spcBef>
+              <a:spcAft>
+                <a:spcPts val="100"/>
+              </a:spcAft>
+            </a:pPr>
+            <a:r>
+              <a:rPr sz="900">
+                <a:solidFill>
+                  <a:srgbClr val="78808C"/>
+                </a:solidFill>
+                <a:latin typeface="Consolas"/>
+              </a:rPr>
+              <a:t>16:40–17:00 </a:t>
+            </a:r>
+            <a:r>
+              <a:rPr sz="1200" b="1">
+                <a:solidFill>
+                  <a:srgbClr val="3D5466"/>
+                </a:solidFill>
+                <a:latin typeface="Arial"/>
+              </a:rPr>
+              <a:t>  Transfer + Covenants</a:t>
+            </a:r>
+            <a:r>
+              <a:rPr sz="900">
+                <a:solidFill>
+                  <a:srgbClr val="78808C"/>
+                </a:solidFill>
+                <a:latin typeface="Arial"/>
+              </a:rPr>
+              <a:t>  ·  Plenum</a:t>
+            </a:r>
+          </a:p>
+          <a:p>
+            <a:pPr>
+              <a:spcBef>
+                <a:spcPts val="400"/>
+              </a:spcBef>
+              <a:spcAft>
+                <a:spcPts val="100"/>
+              </a:spcAft>
+            </a:pPr>
+            <a:r>
+              <a:rPr sz="900">
+                <a:solidFill>
+                  <a:srgbClr val="78808C"/>
+                </a:solidFill>
+                <a:latin typeface="Consolas"/>
+              </a:rPr>
+              <a:t>17:00–17:15 </a:t>
+            </a:r>
+            <a:r>
+              <a:rPr sz="1200" b="1">
+                <a:solidFill>
+                  <a:srgbClr val="3D5466"/>
+                </a:solidFill>
+                <a:latin typeface="Arial"/>
+              </a:rPr>
+              <a:t>  Reflexion + Abschluss</a:t>
             </a:r>
             <a:r>
               <a:rPr sz="900">

</xml_diff>